<commit_message>
feat(standards): anchor TeraFlow-to-ns3 in 3GPP TS 28.561 NdtJob model with ITU-T Q.5040 signaling
</commit_message>
<xml_diff>
--- a/Telecom_Digital_Twin_Adapters_and_Standards.pptx
+++ b/Telecom_Digital_Twin_Adapters_and_Standards.pptx
@@ -4306,128 +4306,6 @@
           </a:solidFill>
           <a:ln w="19050">
             <a:solidFill>
-              <a:srgbClr val="C084FC"/>
-            </a:solidFill>
-          </a:ln>
-        </p:spPr>
-        <p:style>
-          <a:lnRef idx="1">
-            <a:schemeClr val="accent1"/>
-          </a:lnRef>
-          <a:fillRef idx="3">
-            <a:schemeClr val="accent1"/>
-          </a:fillRef>
-          <a:effectRef idx="2">
-            <a:schemeClr val="accent1"/>
-          </a:effectRef>
-          <a:fontRef idx="minor">
-            <a:schemeClr val="lt1"/>
-          </a:fontRef>
-        </p:style>
-        <p:txBody>
-          <a:bodyPr rtlCol="0" anchor="ctr" wrap="square" lIns="182880" rIns="182880" tIns="164592"/>
-          <a:lstStyle/>
-          <a:p>
-            <a:pPr algn="ctr"/>
-            <a:r>
-              <a:rPr sz="1300" b="1">
-                <a:solidFill>
-                  <a:srgbClr val="C084FC"/>
-                </a:solidFill>
-              </a:rPr>
-              <a:t>TM Forum TMF921  </a:t>
-            </a:r>
-            <a:r>
-              <a:rPr sz="900" b="1">
-                <a:solidFill>
-                  <a:srgbClr val="94A3B8"/>
-                </a:solidFill>
-              </a:rPr>
-              <a:t>[BUSINESS &amp; SLA]</a:t>
-            </a:r>
-          </a:p>
-          <a:p>
-            <a:pPr>
-              <a:spcBef>
-                <a:spcPts val="200"/>
-              </a:spcBef>
-              <a:defRPr sz="1100" b="1">
-                <a:solidFill>
-                  <a:srgbClr val="F8FAFC"/>
-                </a:solidFill>
-              </a:defRPr>
-            </a:pPr>
-            <a:r>
-              <a:t>Intent Management API</a:t>
-            </a:r>
-          </a:p>
-          <a:p>
-            <a:pPr>
-              <a:spcBef>
-                <a:spcPts val="400"/>
-              </a:spcBef>
-            </a:pPr>
-            <a:r>
-              <a:rPr b="1" sz="950">
-                <a:solidFill>
-                  <a:srgbClr val="94A3B8"/>
-                </a:solidFill>
-              </a:rPr>
-              <a:t>Standard: </a:t>
-            </a:r>
-            <a:r>
-              <a:rPr sz="950">
-                <a:solidFill>
-                  <a:srgbClr val="F8FAFC"/>
-                </a:solidFill>
-              </a:rPr>
-              <a:t>REST API standard for expressing declarative network intent and SLA expectations.</a:t>
-            </a:r>
-          </a:p>
-          <a:p>
-            <a:pPr>
-              <a:spcBef>
-                <a:spcPts val="400"/>
-              </a:spcBef>
-            </a:pPr>
-            <a:r>
-              <a:rPr b="1" sz="950">
-                <a:solidFill>
-                  <a:srgbClr val="00D4FF"/>
-                </a:solidFill>
-              </a:rPr>
-              <a:t>In Our Platform: </a:t>
-            </a:r>
-            <a:r>
-              <a:rPr sz="950">
-                <a:solidFill>
-                  <a:srgbClr val="F8FAFC"/>
-                </a:solidFill>
-              </a:rPr>
-              <a:t>Operator defines latency (&lt; 1.5ms) and availability without writing low-level scripts. Tracks intent state: Acknowledged → In Evaluation → Compliant.</a:t>
-            </a:r>
-          </a:p>
-        </p:txBody>
-      </p:sp>
-      <p:sp>
-        <p:nvSpPr>
-          <p:cNvPr id="6" name="Rounded Rectangle 5"/>
-          <p:cNvSpPr/>
-          <p:nvPr/>
-        </p:nvSpPr>
-        <p:spPr>
-          <a:xfrm>
-            <a:off x="4379976" y="1554480"/>
-            <a:ext cx="3429000" cy="2331720"/>
-          </a:xfrm>
-          <a:prstGeom prst="roundRect">
-            <a:avLst/>
-          </a:prstGeom>
-          <a:solidFill>
-            <a:srgbClr val="1A2639"/>
-          </a:solidFill>
-          <a:ln w="19050">
-            <a:solidFill>
               <a:srgbClr val="10B981"/>
             </a:solidFill>
           </a:ln>
@@ -4465,7 +4343,7 @@
                   <a:srgbClr val="94A3B8"/>
                 </a:solidFill>
               </a:rPr>
-              <a:t>[5G / 6G CORE]</a:t>
+              <a:t>[PRIMARY APPROVED ANCHOR]</a:t>
             </a:r>
           </a:p>
           <a:p>
@@ -4480,7 +4358,7 @@
               </a:defRPr>
             </a:pPr>
             <a:r>
-              <a:t>Network Digital Twin (NDT) Lifecycle</a:t>
+              <a:t>NDT Management Service &amp; NdtJob Model</a:t>
             </a:r>
           </a:p>
           <a:p>
@@ -4503,7 +4381,7 @@
                   <a:srgbClr val="F8FAFC"/>
                 </a:solidFill>
               </a:rPr>
-              <a:t>3GPP 5G/6G standard defining digital twin management services and closed-loop control.</a:t>
+              <a:t>Approved 3GPP Rel-18/19 specification standardizing the NDT_MnS, NdtJob model, and simulation result semantics.</a:t>
             </a:r>
           </a:p>
           <a:p>
@@ -4526,20 +4404,20 @@
                   <a:srgbClr val="F8FAFC"/>
                 </a:solidFill>
               </a:rPr>
-              <a:t>Governs the 4-phase pre-flight verification gate before any action is actuated: verifies latency envelope, queue stability, jitter, and spectral mask.</a:t>
-            </a:r>
-          </a:p>
-        </p:txBody>
-      </p:sp>
-      <p:sp>
-        <p:nvSpPr>
-          <p:cNvPr id="7" name="Rounded Rectangle 6"/>
+              <a:t>Primary Anchor for TeraFlow-to-NS-3: TFS instantiates an NdtSimulationJob, runs scoped co-simulation, and ingests standardized SimulationResult (PDB, PER, breach prediction).</a:t>
+            </a:r>
+          </a:p>
+        </p:txBody>
+      </p:sp>
+      <p:sp>
+        <p:nvSpPr>
+          <p:cNvPr id="6" name="Rounded Rectangle 5"/>
           <p:cNvSpPr/>
           <p:nvPr/>
         </p:nvSpPr>
         <p:spPr>
           <a:xfrm>
-            <a:off x="8028431" y="1554480"/>
+            <a:off x="4379976" y="1554480"/>
             <a:ext cx="3429000" cy="2331720"/>
           </a:xfrm>
           <a:prstGeom prst="roundRect">
@@ -4579,7 +4457,7 @@
                   <a:srgbClr val="00D4FF"/>
                 </a:solidFill>
               </a:rPr>
-              <a:t>ITU-T Y.3090  </a:t>
+              <a:t>ITU-T Q.5040  </a:t>
             </a:r>
             <a:r>
               <a:rPr sz="900" b="1">
@@ -4587,7 +4465,7 @@
                   <a:srgbClr val="94A3B8"/>
                 </a:solidFill>
               </a:rPr>
-              <a:t>[ARCHITECTURE]</a:t>
+              <a:t>[FUTURE SIGNALING PROTOCOL]</a:t>
             </a:r>
           </a:p>
           <a:p>
@@ -4602,7 +4480,7 @@
               </a:defRPr>
             </a:pPr>
             <a:r>
-              <a:t>Digital Twin Network (DTN) Architecture</a:t>
+              <a:t>Signaling Architecture &amp; Control for DTN</a:t>
             </a:r>
           </a:p>
           <a:p>
@@ -4625,7 +4503,7 @@
                   <a:srgbClr val="F8FAFC"/>
                 </a:solidFill>
               </a:rPr>
-              <a:t>ITU-T standard defining the 3-layer Digital Twin reference model and synchronization.</a:t>
+              <a:t>ITU-T SG11 standard defining signaling procedures for simulation task invocation (Sim-Task-Req), execution control, and KPI streaming.</a:t>
             </a:r>
           </a:p>
           <a:p>
@@ -4648,7 +4526,129 @@
                   <a:srgbClr val="F8FAFC"/>
                 </a:solidFill>
               </a:rPr>
-              <a:t>Defines data repository synchronization between the Physical Network Layer and the Cyber Twin Layer. Powers our real-time shadow datastore.</a:t>
+              <a:t>The likely future signaling standard over the wire for our REST/JSON and SSH RPC bridge between TeraFlowSDN and NS-3 on cersrv-029.</a:t>
+            </a:r>
+          </a:p>
+        </p:txBody>
+      </p:sp>
+      <p:sp>
+        <p:nvSpPr>
+          <p:cNvPr id="7" name="Rounded Rectangle 6"/>
+          <p:cNvSpPr/>
+          <p:nvPr/>
+        </p:nvSpPr>
+        <p:spPr>
+          <a:xfrm>
+            <a:off x="8028431" y="1554480"/>
+            <a:ext cx="3429000" cy="2331720"/>
+          </a:xfrm>
+          <a:prstGeom prst="roundRect">
+            <a:avLst/>
+          </a:prstGeom>
+          <a:solidFill>
+            <a:srgbClr val="1A2639"/>
+          </a:solidFill>
+          <a:ln w="19050">
+            <a:solidFill>
+              <a:srgbClr val="C084FC"/>
+            </a:solidFill>
+          </a:ln>
+        </p:spPr>
+        <p:style>
+          <a:lnRef idx="1">
+            <a:schemeClr val="accent1"/>
+          </a:lnRef>
+          <a:fillRef idx="3">
+            <a:schemeClr val="accent1"/>
+          </a:fillRef>
+          <a:effectRef idx="2">
+            <a:schemeClr val="accent1"/>
+          </a:effectRef>
+          <a:fontRef idx="minor">
+            <a:schemeClr val="lt1"/>
+          </a:fontRef>
+        </p:style>
+        <p:txBody>
+          <a:bodyPr rtlCol="0" anchor="ctr" wrap="square" lIns="182880" rIns="182880" tIns="164592"/>
+          <a:lstStyle/>
+          <a:p>
+            <a:pPr algn="ctr"/>
+            <a:r>
+              <a:rPr sz="1300" b="1">
+                <a:solidFill>
+                  <a:srgbClr val="C084FC"/>
+                </a:solidFill>
+              </a:rPr>
+              <a:t>ITU-T Y.3090 / Y.3092  </a:t>
+            </a:r>
+            <a:r>
+              <a:rPr sz="900" b="1">
+                <a:solidFill>
+                  <a:srgbClr val="94A3B8"/>
+                </a:solidFill>
+              </a:rPr>
+              <a:t>[DTN ARCH &amp; MMEF]</a:t>
+            </a:r>
+          </a:p>
+          <a:p>
+            <a:pPr>
+              <a:spcBef>
+                <a:spcPts val="200"/>
+              </a:spcBef>
+              <a:defRPr sz="1100" b="1">
+                <a:solidFill>
+                  <a:srgbClr val="F8FAFC"/>
+                </a:solidFill>
+              </a:defRPr>
+            </a:pPr>
+            <a:r>
+              <a:t>DTN Architecture &amp; Model Management (MMEF)</a:t>
+            </a:r>
+          </a:p>
+          <a:p>
+            <a:pPr>
+              <a:spcBef>
+                <a:spcPts val="400"/>
+              </a:spcBef>
+            </a:pPr>
+            <a:r>
+              <a:rPr b="1" sz="950">
+                <a:solidFill>
+                  <a:srgbClr val="94A3B8"/>
+                </a:solidFill>
+              </a:rPr>
+              <a:t>Standard: </a:t>
+            </a:r>
+            <a:r>
+              <a:rPr sz="950">
+                <a:solidFill>
+                  <a:srgbClr val="F8FAFC"/>
+                </a:solidFill>
+              </a:rPr>
+              <a:t>ITU-T SG13 3-layer DTN model (Y.3090) and Model Management &amp; Execution Framework (Y.3092) for model fidelity selection.</a:t>
+            </a:r>
+          </a:p>
+          <a:p>
+            <a:pPr>
+              <a:spcBef>
+                <a:spcPts val="400"/>
+              </a:spcBef>
+            </a:pPr>
+            <a:r>
+              <a:rPr b="1" sz="950">
+                <a:solidFill>
+                  <a:srgbClr val="00D4FF"/>
+                </a:solidFill>
+              </a:rPr>
+              <a:t>In Our Platform: </a:t>
+            </a:r>
+            <a:r>
+              <a:rPr sz="950">
+                <a:solidFill>
+                  <a:srgbClr val="F8FAFC"/>
+                </a:solidFill>
+              </a:rPr>
+              <a:t>Dictates our 5-Tier Simulation Resolution Governor (balancing model accuracy vs computation time) and shadow datastore sync.</a:t>
             </a:r>
           </a:p>
         </p:txBody>
@@ -4672,7 +4672,7 @@
           </a:solidFill>
           <a:ln w="19050">
             <a:solidFill>
-              <a:srgbClr val="F59E0B"/>
+              <a:srgbClr val="C084FC"/>
             </a:solidFill>
           </a:ln>
         </p:spPr>
@@ -4698,10 +4698,10 @@
             <a:r>
               <a:rPr sz="1300" b="1">
                 <a:solidFill>
-                  <a:srgbClr val="F59E0B"/>
-                </a:solidFill>
-              </a:rPr>
-              <a:t>IETF NMRG DTI  </a:t>
+                  <a:srgbClr val="C084FC"/>
+                </a:solidFill>
+              </a:rPr>
+              <a:t>TM Forum TMF921  </a:t>
             </a:r>
             <a:r>
               <a:rPr sz="900" b="1">
@@ -4709,7 +4709,7 @@
                   <a:srgbClr val="94A3B8"/>
                 </a:solidFill>
               </a:rPr>
-              <a:t>[SIMULATION SBI]</a:t>
+              <a:t>[BUSINESS &amp; SLA]</a:t>
             </a:r>
           </a:p>
           <a:p>
@@ -4724,7 +4724,7 @@
               </a:defRPr>
             </a:pPr>
             <a:r>
-              <a:t>Digital Twin Interface (RFC Draft)</a:t>
+              <a:t>Intent Management REST API</a:t>
             </a:r>
           </a:p>
           <a:p>
@@ -4747,7 +4747,7 @@
                   <a:srgbClr val="F8FAFC"/>
                 </a:solidFill>
               </a:rPr>
-              <a:t>IETF Network Management Research Group interface for Twin-to-Simulator communication.</a:t>
+              <a:t>REST API standard for expressing declarative network intent and SLA expectations.</a:t>
             </a:r>
           </a:p>
           <a:p>
@@ -4770,7 +4770,7 @@
                   <a:srgbClr val="F8FAFC"/>
                 </a:solidFill>
               </a:rPr>
-              <a:t>Standardizes the East-West protocol for injecting What-If perturbations (traffic surge, rain fade) and streaming discrete telemetry back to controller.</a:t>
+              <a:t>Operator defines latency (&lt; 1.5ms) and availability without writing low-level scripts. Tracks intent state: Acknowledged → In Evaluation → Compliant.</a:t>
             </a:r>
           </a:p>
         </p:txBody>
@@ -5145,7 +5145,7 @@
               </a:defRPr>
             </a:pPr>
             <a:r>
-              <a:t>Adapter 1: TFS-to-NS-3 Simulation Adapter (The Cyber Mirror)</a:t>
+              <a:t>Adapter 1: TeraFlow-to-NS-3 Simulation Adapter (3GPP TS 28.561 &amp; Q.5040)</a:t>
             </a:r>
           </a:p>
         </p:txBody>
@@ -5199,7 +5199,7 @@
               </a:defRPr>
             </a:pPr>
             <a:r>
-              <a:t>🔁 Step-by-Step Functional Flow (Simplified)</a:t>
+              <a:t>🔁 Step-by-Step Functional Flow (3GPP TS 28.561 &amp; Q.5040)</a:t>
             </a:r>
           </a:p>
           <a:p>
@@ -5215,7 +5215,7 @@
                 </a:solidFill>
               </a:rPr>
               <a:t>
-Step 1: Reconcile Live Topology &amp; State
+Step 1: TFS Context → 3GPP NDTI State Sync
 </a:t>
             </a:r>
             <a:r>
@@ -5224,7 +5224,7 @@
                   <a:srgbClr val="F8FAFC"/>
                 </a:solidFill>
               </a:rPr>
-              <a:t>The adapter queries ETSI TeraFlowSDN (:8088 Context) to extract the active 34-node graph, link bandwidths, and live Ceragon RF metrics (RSSI -58 dBm, MCS 8).</a:t>
+              <a:t>The adapter queries ETSI TeraFlowSDN (:8088 Context) to populate the active 3GPP Network Digital Twin Instance (NDTI) with live 34-node topology, link capacities, and Ceragon RF metrics (RSSI -58 dBm, MCS 8).</a:t>
             </a:r>
           </a:p>
           <a:p>
@@ -5236,11 +5236,36 @@
             <a:r>
               <a:rPr sz="1150" b="1">
                 <a:solidFill>
+                  <a:srgbClr val="10B981"/>
+                </a:solidFill>
+              </a:rPr>
+              <a:t>
+Step 2: 3GPP NdtJob Creation &amp; Y.3092 Scoping
+</a:t>
+            </a:r>
+            <a:r>
+              <a:rPr sz="1050">
+                <a:solidFill>
+                  <a:srgbClr val="F8FAFC"/>
+                </a:solidFill>
+              </a:rPr>
+              <a:t>Instantiates a standardized 3GPP NdtSimulationJob. The ITU-T Y.3092 Governor automatically scopes the graph to Tier 4: URLLC Micro-Packet (23 nodes, 95% fidelity) executing in ~1150ms.</a:t>
+            </a:r>
+          </a:p>
+          <a:p>
+            <a:pPr>
+              <a:spcBef>
+                <a:spcPts val="400"/>
+              </a:spcBef>
+            </a:pPr>
+            <a:r>
+              <a:rPr sz="1150" b="1">
+                <a:solidFill>
                   <a:srgbClr val="00D4FF"/>
                 </a:solidFill>
               </a:rPr>
               <a:t>
-Step 2: Simulation Resolution Governor (Fidelity Scoping)
+Step 3: Q.5040 Simulation Task Signaling
 </a:t>
             </a:r>
             <a:r>
@@ -5249,7 +5274,7 @@
                   <a:srgbClr val="F8FAFC"/>
                 </a:solidFill>
               </a:rPr>
-              <a:t>Instead of simulating all 34 nodes (which takes minutes), the Governor automatically scopes the graph to the relevant target domain (e.g. Tier 4: URLLC Micro-Packet, 23 nodes) executing in ~1150ms.</a:t>
+              <a:t>Dispatches task to discrete core on cersrv-029 following the ITU-T Q.5040 signaling pattern (Sim-Task-Req), injecting a 3.5x bulk traffic surge (bufferbloat) or ITU-R P.838 rain fade.</a:t>
             </a:r>
           </a:p>
           <a:p>
@@ -5265,7 +5290,7 @@
                 </a:solidFill>
               </a:rPr>
               <a:t>
-Step 3: What-If Perturbation Dispatch
+Step 4: 3GPP SimulationResult Semantics &amp; Trace Ingestion
 </a:t>
             </a:r>
             <a:r>
@@ -5274,32 +5299,7 @@
                   <a:srgbClr val="F8FAFC"/>
                 </a:solidFill>
               </a:rPr>
-              <a:t>Injects real-world stress conditions into NS-3: 3.5x bulk traffic surge (bufferbloat) or ITU-R P.838 rain fade (ACM rate degradation from 1Gbps to 100Mbps).</a:t>
-            </a:r>
-          </a:p>
-          <a:p>
-            <a:pPr>
-              <a:spcBef>
-                <a:spcPts val="400"/>
-              </a:spcBef>
-            </a:pPr>
-            <a:r>
-              <a:rPr sz="1150" b="1">
-                <a:solidFill>
-                  <a:srgbClr val="10B981"/>
-                </a:solidFill>
-              </a:rPr>
-              <a:t>
-Step 4: Discrete Trace Ingestion &amp; NetAnim Generation
-</a:t>
-            </a:r>
-            <a:r>
-              <a:rPr sz="1050">
-                <a:solidFill>
-                  <a:srgbClr val="F8FAFC"/>
-                </a:solidFill>
-              </a:rPr>
-              <a:t>NS-3 simulates microsecond discrete packet events on cersrv-029, generates /tmp/tsn_wifi_ceragon_anim.xml, and the adapter streams packet queues, buffer drops, and latencies back to the twin.</a:t>
+              <a:t>Ingests standardized 3GPP SimulationResult semantics (predicted PDB latency, PER loss, queue depth, slaBreachPredicted verdict) and discrete NetAnim trace to gate physical actuation.</a:t>
             </a:r>
           </a:p>
         </p:txBody>
@@ -5354,6 +5354,102 @@
             </a:pPr>
             <a:r>
               <a:t>⚙️ Key Implementation Features</a:t>
+            </a:r>
+          </a:p>
+          <a:p>
+            <a:pPr>
+              <a:spcBef>
+                <a:spcPts val="400"/>
+              </a:spcBef>
+            </a:pPr>
+            <a:r>
+              <a:rPr sz="1050" b="1">
+                <a:solidFill>
+                  <a:srgbClr val="00D4FF"/>
+                </a:solidFill>
+              </a:rPr>
+              <a:t>
+• 3GPP TS 28.561 NDT_MnS: </a:t>
+            </a:r>
+            <a:r>
+              <a:rPr sz="1000">
+                <a:solidFill>
+                  <a:srgbClr val="94A3B8"/>
+                </a:solidFill>
+              </a:rPr>
+              <a:t>Implements approved 3GPP NDT management service operations: job parameterization, target subnetwork scoping, and simulation result semantics.</a:t>
+            </a:r>
+          </a:p>
+          <a:p>
+            <a:pPr>
+              <a:spcBef>
+                <a:spcPts val="400"/>
+              </a:spcBef>
+            </a:pPr>
+            <a:r>
+              <a:rPr sz="1050" b="1">
+                <a:solidFill>
+                  <a:srgbClr val="00D4FF"/>
+                </a:solidFill>
+              </a:rPr>
+              <a:t>
+• ITU-T Q.5040 Signaling: </a:t>
+            </a:r>
+            <a:r>
+              <a:rPr sz="1000">
+                <a:solidFill>
+                  <a:srgbClr val="94A3B8"/>
+                </a:solidFill>
+              </a:rPr>
+              <a:t>Adopts the emerging Q.5040 task invocation and report signaling pattern between ETSI TeraFlowSDN and the remote NS-3 simulation engine.</a:t>
+            </a:r>
+          </a:p>
+          <a:p>
+            <a:pPr>
+              <a:spcBef>
+                <a:spcPts val="400"/>
+              </a:spcBef>
+            </a:pPr>
+            <a:r>
+              <a:rPr sz="1050" b="1">
+                <a:solidFill>
+                  <a:srgbClr val="00D4FF"/>
+                </a:solidFill>
+              </a:rPr>
+              <a:t>
+• Multi-Tier Y.3092 Governor: </a:t>
+            </a:r>
+            <a:r>
+              <a:rPr sz="1000">
+                <a:solidFill>
+                  <a:srgbClr val="94A3B8"/>
+                </a:solidFill>
+              </a:rPr>
+              <a:t>5 Resolution Tiers (Macro-Topology 25%, Queue Dynamics 55%, Physical RF 75%, URLLC 95%, Green Energy 20%).</a:t>
+            </a:r>
+          </a:p>
+          <a:p>
+            <a:pPr>
+              <a:spcBef>
+                <a:spcPts val="400"/>
+              </a:spcBef>
+            </a:pPr>
+            <a:r>
+              <a:rPr sz="1050" b="1">
+                <a:solidFill>
+                  <a:srgbClr val="00D4FF"/>
+                </a:solidFill>
+              </a:rPr>
+              <a:t>
+• NetAnim Discrete Replay: </a:t>
+            </a:r>
+            <a:r>
+              <a:rPr sz="1000">
+                <a:solidFill>
+                  <a:srgbClr val="94A3B8"/>
+                </a:solidFill>
+              </a:rPr>
+              <a:t>Instruments AnimationInterface for real timeline playback (0.000s - 2.500s) with 10 visual buffer slots and tail-drop alerts.</a:t>
             </a:r>
           </a:p>
           <a:p>

</xml_diff>